<commit_message>
Dokumentation, anpassung Android 17, UI modus klasse
</commit_message>
<xml_diff>
--- a/Docs.pptx
+++ b/Docs.pptx
@@ -6,9 +6,10 @@
   </p:sldMasterIdLst>
   <p:sldIdLst>
     <p:sldId id="256" r:id="rId2"/>
-    <p:sldId id="257" r:id="rId3"/>
-    <p:sldId id="258" r:id="rId4"/>
-    <p:sldId id="259" r:id="rId5"/>
+    <p:sldId id="260" r:id="rId3"/>
+    <p:sldId id="257" r:id="rId4"/>
+    <p:sldId id="258" r:id="rId5"/>
+    <p:sldId id="259" r:id="rId6"/>
   </p:sldIdLst>
   <p:sldSz cx="12192000" cy="6858000"/>
   <p:notesSz cx="6858000" cy="9144000"/>
@@ -262,7 +263,7 @@
           <a:p>
             <a:fld id="{191EFF39-64BE-4380-8A53-06CF69B4C7AB}" type="datetimeFigureOut">
               <a:rPr lang="de-DE" smtClean="0"/>
-              <a:t>15.07.2026</a:t>
+              <a:t>16.07.2026</a:t>
             </a:fld>
             <a:endParaRPr lang="de-DE"/>
           </a:p>
@@ -460,7 +461,7 @@
           <a:p>
             <a:fld id="{191EFF39-64BE-4380-8A53-06CF69B4C7AB}" type="datetimeFigureOut">
               <a:rPr lang="de-DE" smtClean="0"/>
-              <a:t>15.07.2026</a:t>
+              <a:t>16.07.2026</a:t>
             </a:fld>
             <a:endParaRPr lang="de-DE"/>
           </a:p>
@@ -668,7 +669,7 @@
           <a:p>
             <a:fld id="{191EFF39-64BE-4380-8A53-06CF69B4C7AB}" type="datetimeFigureOut">
               <a:rPr lang="de-DE" smtClean="0"/>
-              <a:t>15.07.2026</a:t>
+              <a:t>16.07.2026</a:t>
             </a:fld>
             <a:endParaRPr lang="de-DE"/>
           </a:p>
@@ -866,7 +867,7 @@
           <a:p>
             <a:fld id="{191EFF39-64BE-4380-8A53-06CF69B4C7AB}" type="datetimeFigureOut">
               <a:rPr lang="de-DE" smtClean="0"/>
-              <a:t>15.07.2026</a:t>
+              <a:t>16.07.2026</a:t>
             </a:fld>
             <a:endParaRPr lang="de-DE"/>
           </a:p>
@@ -1141,7 +1142,7 @@
           <a:p>
             <a:fld id="{191EFF39-64BE-4380-8A53-06CF69B4C7AB}" type="datetimeFigureOut">
               <a:rPr lang="de-DE" smtClean="0"/>
-              <a:t>15.07.2026</a:t>
+              <a:t>16.07.2026</a:t>
             </a:fld>
             <a:endParaRPr lang="de-DE"/>
           </a:p>
@@ -1406,7 +1407,7 @@
           <a:p>
             <a:fld id="{191EFF39-64BE-4380-8A53-06CF69B4C7AB}" type="datetimeFigureOut">
               <a:rPr lang="de-DE" smtClean="0"/>
-              <a:t>15.07.2026</a:t>
+              <a:t>16.07.2026</a:t>
             </a:fld>
             <a:endParaRPr lang="de-DE"/>
           </a:p>
@@ -1818,7 +1819,7 @@
           <a:p>
             <a:fld id="{191EFF39-64BE-4380-8A53-06CF69B4C7AB}" type="datetimeFigureOut">
               <a:rPr lang="de-DE" smtClean="0"/>
-              <a:t>15.07.2026</a:t>
+              <a:t>16.07.2026</a:t>
             </a:fld>
             <a:endParaRPr lang="de-DE"/>
           </a:p>
@@ -1959,7 +1960,7 @@
           <a:p>
             <a:fld id="{191EFF39-64BE-4380-8A53-06CF69B4C7AB}" type="datetimeFigureOut">
               <a:rPr lang="de-DE" smtClean="0"/>
-              <a:t>15.07.2026</a:t>
+              <a:t>16.07.2026</a:t>
             </a:fld>
             <a:endParaRPr lang="de-DE"/>
           </a:p>
@@ -2072,7 +2073,7 @@
           <a:p>
             <a:fld id="{191EFF39-64BE-4380-8A53-06CF69B4C7AB}" type="datetimeFigureOut">
               <a:rPr lang="de-DE" smtClean="0"/>
-              <a:t>15.07.2026</a:t>
+              <a:t>16.07.2026</a:t>
             </a:fld>
             <a:endParaRPr lang="de-DE"/>
           </a:p>
@@ -2383,7 +2384,7 @@
           <a:p>
             <a:fld id="{191EFF39-64BE-4380-8A53-06CF69B4C7AB}" type="datetimeFigureOut">
               <a:rPr lang="de-DE" smtClean="0"/>
-              <a:t>15.07.2026</a:t>
+              <a:t>16.07.2026</a:t>
             </a:fld>
             <a:endParaRPr lang="de-DE"/>
           </a:p>
@@ -2671,7 +2672,7 @@
           <a:p>
             <a:fld id="{191EFF39-64BE-4380-8A53-06CF69B4C7AB}" type="datetimeFigureOut">
               <a:rPr lang="de-DE" smtClean="0"/>
-              <a:t>15.07.2026</a:t>
+              <a:t>16.07.2026</a:t>
             </a:fld>
             <a:endParaRPr lang="de-DE"/>
           </a:p>
@@ -2912,7 +2913,7 @@
           <a:p>
             <a:fld id="{191EFF39-64BE-4380-8A53-06CF69B4C7AB}" type="datetimeFigureOut">
               <a:rPr lang="de-DE" smtClean="0"/>
-              <a:t>15.07.2026</a:t>
+              <a:t>16.07.2026</a:t>
             </a:fld>
             <a:endParaRPr lang="de-DE"/>
           </a:p>
@@ -4682,6 +4683,991 @@
         <p:cNvPr id="1" name="">
           <a:extLst>
             <a:ext uri="{FF2B5EF4-FFF2-40B4-BE49-F238E27FC236}">
+              <a16:creationId xmlns:a16="http://schemas.microsoft.com/office/drawing/2014/main" id="{34D7686D-21C2-CB72-00C0-CC346F91AE87}"/>
+            </a:ext>
+          </a:extLst>
+        </p:cNvPr>
+        <p:cNvGrpSpPr/>
+        <p:nvPr/>
+      </p:nvGrpSpPr>
+      <p:grpSpPr>
+        <a:xfrm>
+          <a:off x="0" y="0"/>
+          <a:ext cx="0" cy="0"/>
+          <a:chOff x="0" y="0"/>
+          <a:chExt cx="0" cy="0"/>
+        </a:xfrm>
+      </p:grpSpPr>
+      <p:sp>
+        <p:nvSpPr>
+          <p:cNvPr id="4" name="Rechteck 3">
+            <a:extLst>
+              <a:ext uri="{FF2B5EF4-FFF2-40B4-BE49-F238E27FC236}">
+                <a16:creationId xmlns:a16="http://schemas.microsoft.com/office/drawing/2014/main" id="{B07CA7E1-9A60-C36D-1A5D-C55A8448B106}"/>
+              </a:ext>
+            </a:extLst>
+          </p:cNvPr>
+          <p:cNvSpPr/>
+          <p:nvPr/>
+        </p:nvSpPr>
+        <p:spPr>
+          <a:xfrm>
+            <a:off x="1392011" y="2106386"/>
+            <a:ext cx="145143" cy="5667828"/>
+          </a:xfrm>
+          <a:prstGeom prst="rect">
+            <a:avLst/>
+          </a:prstGeom>
+          <a:solidFill>
+            <a:srgbClr val="00B0F0"/>
+          </a:solidFill>
+          <a:ln>
+            <a:solidFill>
+              <a:srgbClr val="00B0F0"/>
+            </a:solidFill>
+          </a:ln>
+        </p:spPr>
+        <p:style>
+          <a:lnRef idx="2">
+            <a:schemeClr val="accent1">
+              <a:shade val="15000"/>
+            </a:schemeClr>
+          </a:lnRef>
+          <a:fillRef idx="1">
+            <a:schemeClr val="accent1"/>
+          </a:fillRef>
+          <a:effectRef idx="0">
+            <a:schemeClr val="accent1"/>
+          </a:effectRef>
+          <a:fontRef idx="minor">
+            <a:schemeClr val="lt1"/>
+          </a:fontRef>
+        </p:style>
+        <p:txBody>
+          <a:bodyPr rtlCol="0" anchor="ctr"/>
+          <a:lstStyle/>
+          <a:p>
+            <a:pPr algn="ctr"/>
+            <a:endParaRPr lang="de-DE"/>
+          </a:p>
+        </p:txBody>
+      </p:sp>
+      <p:sp>
+        <p:nvSpPr>
+          <p:cNvPr id="8" name="Rechteck 7">
+            <a:extLst>
+              <a:ext uri="{FF2B5EF4-FFF2-40B4-BE49-F238E27FC236}">
+                <a16:creationId xmlns:a16="http://schemas.microsoft.com/office/drawing/2014/main" id="{626B3882-8FB2-D6E3-CE8D-038C8711F5D1}"/>
+              </a:ext>
+            </a:extLst>
+          </p:cNvPr>
+          <p:cNvSpPr/>
+          <p:nvPr/>
+        </p:nvSpPr>
+        <p:spPr>
+          <a:xfrm>
+            <a:off x="3968297" y="2106386"/>
+            <a:ext cx="145143" cy="5667828"/>
+          </a:xfrm>
+          <a:prstGeom prst="rect">
+            <a:avLst/>
+          </a:prstGeom>
+          <a:solidFill>
+            <a:srgbClr val="00B0F0"/>
+          </a:solidFill>
+          <a:ln>
+            <a:solidFill>
+              <a:srgbClr val="00B0F0"/>
+            </a:solidFill>
+          </a:ln>
+        </p:spPr>
+        <p:style>
+          <a:lnRef idx="2">
+            <a:schemeClr val="accent1">
+              <a:shade val="15000"/>
+            </a:schemeClr>
+          </a:lnRef>
+          <a:fillRef idx="1">
+            <a:schemeClr val="accent1"/>
+          </a:fillRef>
+          <a:effectRef idx="0">
+            <a:schemeClr val="accent1"/>
+          </a:effectRef>
+          <a:fontRef idx="minor">
+            <a:schemeClr val="lt1"/>
+          </a:fontRef>
+        </p:style>
+        <p:txBody>
+          <a:bodyPr rtlCol="0" anchor="ctr"/>
+          <a:lstStyle/>
+          <a:p>
+            <a:pPr algn="ctr"/>
+            <a:endParaRPr lang="de-DE"/>
+          </a:p>
+        </p:txBody>
+      </p:sp>
+      <p:sp>
+        <p:nvSpPr>
+          <p:cNvPr id="11" name="Textfeld 10">
+            <a:extLst>
+              <a:ext uri="{FF2B5EF4-FFF2-40B4-BE49-F238E27FC236}">
+                <a16:creationId xmlns:a16="http://schemas.microsoft.com/office/drawing/2014/main" id="{A0CF948D-A423-C316-BA44-3644290D4944}"/>
+              </a:ext>
+            </a:extLst>
+          </p:cNvPr>
+          <p:cNvSpPr txBox="1"/>
+          <p:nvPr/>
+        </p:nvSpPr>
+        <p:spPr>
+          <a:xfrm>
+            <a:off x="1841954" y="1155700"/>
+            <a:ext cx="1821543" cy="1200329"/>
+          </a:xfrm>
+          <a:prstGeom prst="rect">
+            <a:avLst/>
+          </a:prstGeom>
+          <a:noFill/>
+        </p:spPr>
+        <p:txBody>
+          <a:bodyPr wrap="square" rtlCol="0">
+            <a:spAutoFit/>
+          </a:bodyPr>
+          <a:lstStyle/>
+          <a:p>
+            <a:pPr algn="ctr"/>
+            <a:r>
+              <a:rPr lang="de-DE" dirty="0"/>
+              <a:t>A</a:t>
+            </a:r>
+          </a:p>
+          <a:p>
+            <a:pPr algn="ctr"/>
+            <a:endParaRPr lang="de-DE" dirty="0"/>
+          </a:p>
+          <a:p>
+            <a:pPr algn="ctr"/>
+            <a:endParaRPr lang="de-DE" dirty="0"/>
+          </a:p>
+          <a:p>
+            <a:pPr algn="ctr"/>
+            <a:endParaRPr lang="de-DE" dirty="0"/>
+          </a:p>
+        </p:txBody>
+      </p:sp>
+      <p:sp>
+        <p:nvSpPr>
+          <p:cNvPr id="13" name="Rechteck 12">
+            <a:extLst>
+              <a:ext uri="{FF2B5EF4-FFF2-40B4-BE49-F238E27FC236}">
+                <a16:creationId xmlns:a16="http://schemas.microsoft.com/office/drawing/2014/main" id="{D46CE05A-CCA7-BAF1-9210-2FF87BA44C48}"/>
+              </a:ext>
+            </a:extLst>
+          </p:cNvPr>
+          <p:cNvSpPr/>
+          <p:nvPr/>
+        </p:nvSpPr>
+        <p:spPr>
+          <a:xfrm>
+            <a:off x="7829096" y="2141890"/>
+            <a:ext cx="145143" cy="5667828"/>
+          </a:xfrm>
+          <a:prstGeom prst="rect">
+            <a:avLst/>
+          </a:prstGeom>
+          <a:solidFill>
+            <a:srgbClr val="00B0F0"/>
+          </a:solidFill>
+          <a:ln>
+            <a:solidFill>
+              <a:srgbClr val="00B0F0"/>
+            </a:solidFill>
+          </a:ln>
+        </p:spPr>
+        <p:style>
+          <a:lnRef idx="2">
+            <a:schemeClr val="accent1">
+              <a:shade val="15000"/>
+            </a:schemeClr>
+          </a:lnRef>
+          <a:fillRef idx="1">
+            <a:schemeClr val="accent1"/>
+          </a:fillRef>
+          <a:effectRef idx="0">
+            <a:schemeClr val="accent1"/>
+          </a:effectRef>
+          <a:fontRef idx="minor">
+            <a:schemeClr val="lt1"/>
+          </a:fontRef>
+        </p:style>
+        <p:txBody>
+          <a:bodyPr rtlCol="0" anchor="ctr"/>
+          <a:lstStyle/>
+          <a:p>
+            <a:pPr algn="ctr"/>
+            <a:endParaRPr lang="de-DE"/>
+          </a:p>
+        </p:txBody>
+      </p:sp>
+      <p:sp>
+        <p:nvSpPr>
+          <p:cNvPr id="15" name="Rechteck 14">
+            <a:extLst>
+              <a:ext uri="{FF2B5EF4-FFF2-40B4-BE49-F238E27FC236}">
+                <a16:creationId xmlns:a16="http://schemas.microsoft.com/office/drawing/2014/main" id="{6AB7A9BD-C99A-3A34-E23E-4EF3EEFF3DF9}"/>
+              </a:ext>
+            </a:extLst>
+          </p:cNvPr>
+          <p:cNvSpPr/>
+          <p:nvPr/>
+        </p:nvSpPr>
+        <p:spPr>
+          <a:xfrm>
+            <a:off x="10405382" y="2141890"/>
+            <a:ext cx="145143" cy="5667828"/>
+          </a:xfrm>
+          <a:prstGeom prst="rect">
+            <a:avLst/>
+          </a:prstGeom>
+          <a:solidFill>
+            <a:srgbClr val="00B0F0"/>
+          </a:solidFill>
+          <a:ln>
+            <a:solidFill>
+              <a:srgbClr val="00B0F0"/>
+            </a:solidFill>
+          </a:ln>
+        </p:spPr>
+        <p:style>
+          <a:lnRef idx="2">
+            <a:schemeClr val="accent1">
+              <a:shade val="15000"/>
+            </a:schemeClr>
+          </a:lnRef>
+          <a:fillRef idx="1">
+            <a:schemeClr val="accent1"/>
+          </a:fillRef>
+          <a:effectRef idx="0">
+            <a:schemeClr val="accent1"/>
+          </a:effectRef>
+          <a:fontRef idx="minor">
+            <a:schemeClr val="lt1"/>
+          </a:fontRef>
+        </p:style>
+        <p:txBody>
+          <a:bodyPr rtlCol="0" anchor="ctr"/>
+          <a:lstStyle/>
+          <a:p>
+            <a:pPr algn="ctr"/>
+            <a:endParaRPr lang="de-DE"/>
+          </a:p>
+        </p:txBody>
+      </p:sp>
+      <p:sp>
+        <p:nvSpPr>
+          <p:cNvPr id="17" name="Textfeld 16">
+            <a:extLst>
+              <a:ext uri="{FF2B5EF4-FFF2-40B4-BE49-F238E27FC236}">
+                <a16:creationId xmlns:a16="http://schemas.microsoft.com/office/drawing/2014/main" id="{A99B731F-2A8A-96BA-5548-6FC02D7C23B1}"/>
+              </a:ext>
+            </a:extLst>
+          </p:cNvPr>
+          <p:cNvSpPr txBox="1"/>
+          <p:nvPr/>
+        </p:nvSpPr>
+        <p:spPr>
+          <a:xfrm>
+            <a:off x="8133896" y="1155700"/>
+            <a:ext cx="1821543" cy="1477328"/>
+          </a:xfrm>
+          <a:prstGeom prst="rect">
+            <a:avLst/>
+          </a:prstGeom>
+          <a:noFill/>
+        </p:spPr>
+        <p:txBody>
+          <a:bodyPr wrap="square" rtlCol="0">
+            <a:spAutoFit/>
+          </a:bodyPr>
+          <a:lstStyle/>
+          <a:p>
+            <a:pPr algn="ctr"/>
+            <a:r>
+              <a:rPr lang="de-DE" dirty="0"/>
+              <a:t>B</a:t>
+            </a:r>
+          </a:p>
+          <a:p>
+            <a:pPr algn="ctr"/>
+            <a:endParaRPr lang="de-DE" dirty="0"/>
+          </a:p>
+          <a:p>
+            <a:pPr algn="ctr"/>
+            <a:endParaRPr lang="de-DE" dirty="0"/>
+          </a:p>
+          <a:p>
+            <a:pPr algn="ctr"/>
+            <a:endParaRPr lang="de-DE" dirty="0"/>
+          </a:p>
+          <a:p>
+            <a:pPr algn="ctr"/>
+            <a:endParaRPr lang="de-DE" dirty="0"/>
+          </a:p>
+        </p:txBody>
+      </p:sp>
+      <p:sp>
+        <p:nvSpPr>
+          <p:cNvPr id="18" name="Textfeld 17">
+            <a:extLst>
+              <a:ext uri="{FF2B5EF4-FFF2-40B4-BE49-F238E27FC236}">
+                <a16:creationId xmlns:a16="http://schemas.microsoft.com/office/drawing/2014/main" id="{FF1FF4BA-7F2E-661C-69FF-E995594BC885}"/>
+              </a:ext>
+            </a:extLst>
+          </p:cNvPr>
+          <p:cNvSpPr txBox="1"/>
+          <p:nvPr/>
+        </p:nvSpPr>
+        <p:spPr>
+          <a:xfrm>
+            <a:off x="680810" y="1634671"/>
+            <a:ext cx="1567543" cy="369332"/>
+          </a:xfrm>
+          <a:prstGeom prst="rect">
+            <a:avLst/>
+          </a:prstGeom>
+          <a:noFill/>
+        </p:spPr>
+        <p:txBody>
+          <a:bodyPr wrap="square" rtlCol="0">
+            <a:spAutoFit/>
+          </a:bodyPr>
+          <a:lstStyle/>
+          <a:p>
+            <a:pPr algn="ctr"/>
+            <a:r>
+              <a:rPr lang="de-DE" dirty="0"/>
+              <a:t>Main </a:t>
+            </a:r>
+            <a:r>
+              <a:rPr lang="de-DE" dirty="0" err="1"/>
+              <a:t>Activity</a:t>
+            </a:r>
+            <a:endParaRPr lang="de-DE" dirty="0"/>
+          </a:p>
+        </p:txBody>
+      </p:sp>
+      <p:sp>
+        <p:nvSpPr>
+          <p:cNvPr id="20" name="Textfeld 19">
+            <a:extLst>
+              <a:ext uri="{FF2B5EF4-FFF2-40B4-BE49-F238E27FC236}">
+                <a16:creationId xmlns:a16="http://schemas.microsoft.com/office/drawing/2014/main" id="{3CFA931B-FF88-5520-94DA-0A92E827EAD9}"/>
+              </a:ext>
+            </a:extLst>
+          </p:cNvPr>
+          <p:cNvSpPr txBox="1"/>
+          <p:nvPr/>
+        </p:nvSpPr>
+        <p:spPr>
+          <a:xfrm>
+            <a:off x="9694181" y="1634671"/>
+            <a:ext cx="1567543" cy="369332"/>
+          </a:xfrm>
+          <a:prstGeom prst="rect">
+            <a:avLst/>
+          </a:prstGeom>
+          <a:noFill/>
+        </p:spPr>
+        <p:txBody>
+          <a:bodyPr wrap="square" rtlCol="0">
+            <a:spAutoFit/>
+          </a:bodyPr>
+          <a:lstStyle/>
+          <a:p>
+            <a:pPr algn="ctr"/>
+            <a:r>
+              <a:rPr lang="de-DE" dirty="0"/>
+              <a:t>Main </a:t>
+            </a:r>
+            <a:r>
+              <a:rPr lang="de-DE" dirty="0" err="1"/>
+              <a:t>Activity</a:t>
+            </a:r>
+            <a:endParaRPr lang="de-DE" dirty="0"/>
+          </a:p>
+        </p:txBody>
+      </p:sp>
+      <p:sp>
+        <p:nvSpPr>
+          <p:cNvPr id="22" name="Textfeld 21">
+            <a:extLst>
+              <a:ext uri="{FF2B5EF4-FFF2-40B4-BE49-F238E27FC236}">
+                <a16:creationId xmlns:a16="http://schemas.microsoft.com/office/drawing/2014/main" id="{F6DAE256-A948-AE25-3CB3-1A77AE5D960E}"/>
+              </a:ext>
+            </a:extLst>
+          </p:cNvPr>
+          <p:cNvSpPr txBox="1"/>
+          <p:nvPr/>
+        </p:nvSpPr>
+        <p:spPr>
+          <a:xfrm>
+            <a:off x="3130096" y="1634671"/>
+            <a:ext cx="1821543" cy="369332"/>
+          </a:xfrm>
+          <a:prstGeom prst="rect">
+            <a:avLst/>
+          </a:prstGeom>
+          <a:noFill/>
+        </p:spPr>
+        <p:txBody>
+          <a:bodyPr wrap="square" rtlCol="0">
+            <a:spAutoFit/>
+          </a:bodyPr>
+          <a:lstStyle/>
+          <a:p>
+            <a:pPr algn="ctr"/>
+            <a:r>
+              <a:rPr lang="de-DE" dirty="0"/>
+              <a:t>OOB Connector</a:t>
+            </a:r>
+          </a:p>
+        </p:txBody>
+      </p:sp>
+      <p:sp>
+        <p:nvSpPr>
+          <p:cNvPr id="24" name="Textfeld 23">
+            <a:extLst>
+              <a:ext uri="{FF2B5EF4-FFF2-40B4-BE49-F238E27FC236}">
+                <a16:creationId xmlns:a16="http://schemas.microsoft.com/office/drawing/2014/main" id="{344C214F-0055-70CD-7549-CC09F128C351}"/>
+              </a:ext>
+            </a:extLst>
+          </p:cNvPr>
+          <p:cNvSpPr txBox="1"/>
+          <p:nvPr/>
+        </p:nvSpPr>
+        <p:spPr>
+          <a:xfrm>
+            <a:off x="6990895" y="1709698"/>
+            <a:ext cx="1821543" cy="369332"/>
+          </a:xfrm>
+          <a:prstGeom prst="rect">
+            <a:avLst/>
+          </a:prstGeom>
+          <a:noFill/>
+        </p:spPr>
+        <p:txBody>
+          <a:bodyPr wrap="square" rtlCol="0">
+            <a:spAutoFit/>
+          </a:bodyPr>
+          <a:lstStyle/>
+          <a:p>
+            <a:pPr algn="ctr"/>
+            <a:r>
+              <a:rPr lang="de-DE" dirty="0"/>
+              <a:t>OOB Connector</a:t>
+            </a:r>
+          </a:p>
+        </p:txBody>
+      </p:sp>
+      <p:sp>
+        <p:nvSpPr>
+          <p:cNvPr id="27" name="Textfeld 26">
+            <a:extLst>
+              <a:ext uri="{FF2B5EF4-FFF2-40B4-BE49-F238E27FC236}">
+                <a16:creationId xmlns:a16="http://schemas.microsoft.com/office/drawing/2014/main" id="{78545669-2938-BDAA-6D34-6C11D23F4FA1}"/>
+              </a:ext>
+            </a:extLst>
+          </p:cNvPr>
+          <p:cNvSpPr txBox="1"/>
+          <p:nvPr/>
+        </p:nvSpPr>
+        <p:spPr>
+          <a:xfrm>
+            <a:off x="1651452" y="2620126"/>
+            <a:ext cx="2434773" cy="246221"/>
+          </a:xfrm>
+          <a:prstGeom prst="rect">
+            <a:avLst/>
+          </a:prstGeom>
+          <a:noFill/>
+        </p:spPr>
+        <p:txBody>
+          <a:bodyPr wrap="square" rtlCol="0">
+            <a:spAutoFit/>
+          </a:bodyPr>
+          <a:lstStyle/>
+          <a:p>
+            <a:r>
+              <a:rPr lang="de-DE" sz="1000" dirty="0" err="1"/>
+              <a:t>oobConnector.stopMeasuring</a:t>
+            </a:r>
+            <a:r>
+              <a:rPr lang="de-DE" sz="1000" dirty="0"/>
+              <a:t>()</a:t>
+            </a:r>
+          </a:p>
+        </p:txBody>
+      </p:sp>
+      <p:cxnSp>
+        <p:nvCxnSpPr>
+          <p:cNvPr id="29" name="Gerade Verbindung mit Pfeil 28">
+            <a:extLst>
+              <a:ext uri="{FF2B5EF4-FFF2-40B4-BE49-F238E27FC236}">
+                <a16:creationId xmlns:a16="http://schemas.microsoft.com/office/drawing/2014/main" id="{AEA1C57B-D232-9C09-7BA2-56F523AB494F}"/>
+              </a:ext>
+            </a:extLst>
+          </p:cNvPr>
+          <p:cNvCxnSpPr/>
+          <p:nvPr/>
+        </p:nvCxnSpPr>
+        <p:spPr>
+          <a:xfrm>
+            <a:off x="1537154" y="2823847"/>
+            <a:ext cx="2431143" cy="130629"/>
+          </a:xfrm>
+          <a:prstGeom prst="straightConnector1">
+            <a:avLst/>
+          </a:prstGeom>
+          <a:ln>
+            <a:prstDash val="solid"/>
+            <a:tailEnd type="triangle"/>
+          </a:ln>
+        </p:spPr>
+        <p:style>
+          <a:lnRef idx="2">
+            <a:schemeClr val="accent1"/>
+          </a:lnRef>
+          <a:fillRef idx="0">
+            <a:schemeClr val="accent1"/>
+          </a:fillRef>
+          <a:effectRef idx="1">
+            <a:schemeClr val="accent1"/>
+          </a:effectRef>
+          <a:fontRef idx="minor">
+            <a:schemeClr val="tx1"/>
+          </a:fontRef>
+        </p:style>
+      </p:cxnSp>
+      <p:cxnSp>
+        <p:nvCxnSpPr>
+          <p:cNvPr id="31" name="Gerade Verbindung mit Pfeil 30">
+            <a:extLst>
+              <a:ext uri="{FF2B5EF4-FFF2-40B4-BE49-F238E27FC236}">
+                <a16:creationId xmlns:a16="http://schemas.microsoft.com/office/drawing/2014/main" id="{732E51A1-C6C3-1A39-5C16-83A0C79EE8C8}"/>
+              </a:ext>
+            </a:extLst>
+          </p:cNvPr>
+          <p:cNvCxnSpPr/>
+          <p:nvPr/>
+        </p:nvCxnSpPr>
+        <p:spPr>
+          <a:xfrm>
+            <a:off x="4113440" y="3059704"/>
+            <a:ext cx="3715656" cy="174671"/>
+          </a:xfrm>
+          <a:prstGeom prst="straightConnector1">
+            <a:avLst/>
+          </a:prstGeom>
+          <a:ln>
+            <a:prstDash val="solid"/>
+            <a:tailEnd type="triangle"/>
+          </a:ln>
+        </p:spPr>
+        <p:style>
+          <a:lnRef idx="2">
+            <a:schemeClr val="accent1"/>
+          </a:lnRef>
+          <a:fillRef idx="0">
+            <a:schemeClr val="accent1"/>
+          </a:fillRef>
+          <a:effectRef idx="1">
+            <a:schemeClr val="accent1"/>
+          </a:effectRef>
+          <a:fontRef idx="minor">
+            <a:schemeClr val="tx1"/>
+          </a:fontRef>
+        </p:style>
+      </p:cxnSp>
+      <p:cxnSp>
+        <p:nvCxnSpPr>
+          <p:cNvPr id="33" name="Gerade Verbindung mit Pfeil 32">
+            <a:extLst>
+              <a:ext uri="{FF2B5EF4-FFF2-40B4-BE49-F238E27FC236}">
+                <a16:creationId xmlns:a16="http://schemas.microsoft.com/office/drawing/2014/main" id="{630DD798-2353-F634-4452-A65F54846AA7}"/>
+              </a:ext>
+            </a:extLst>
+          </p:cNvPr>
+          <p:cNvCxnSpPr/>
+          <p:nvPr/>
+        </p:nvCxnSpPr>
+        <p:spPr>
+          <a:xfrm>
+            <a:off x="7974239" y="3234375"/>
+            <a:ext cx="2380343" cy="111986"/>
+          </a:xfrm>
+          <a:prstGeom prst="straightConnector1">
+            <a:avLst/>
+          </a:prstGeom>
+          <a:ln>
+            <a:prstDash val="solid"/>
+            <a:tailEnd type="triangle"/>
+          </a:ln>
+        </p:spPr>
+        <p:style>
+          <a:lnRef idx="2">
+            <a:schemeClr val="accent1"/>
+          </a:lnRef>
+          <a:fillRef idx="0">
+            <a:schemeClr val="accent1"/>
+          </a:fillRef>
+          <a:effectRef idx="1">
+            <a:schemeClr val="accent1"/>
+          </a:effectRef>
+          <a:fontRef idx="minor">
+            <a:schemeClr val="tx1"/>
+          </a:fontRef>
+        </p:style>
+      </p:cxnSp>
+      <p:sp>
+        <p:nvSpPr>
+          <p:cNvPr id="35" name="Textfeld 34">
+            <a:extLst>
+              <a:ext uri="{FF2B5EF4-FFF2-40B4-BE49-F238E27FC236}">
+                <a16:creationId xmlns:a16="http://schemas.microsoft.com/office/drawing/2014/main" id="{D7C4F106-F526-2629-B75C-EAF4383045E2}"/>
+              </a:ext>
+            </a:extLst>
+          </p:cNvPr>
+          <p:cNvSpPr txBox="1"/>
+          <p:nvPr/>
+        </p:nvSpPr>
+        <p:spPr>
+          <a:xfrm>
+            <a:off x="4681310" y="2838100"/>
+            <a:ext cx="2434773" cy="246221"/>
+          </a:xfrm>
+          <a:prstGeom prst="rect">
+            <a:avLst/>
+          </a:prstGeom>
+          <a:noFill/>
+        </p:spPr>
+        <p:txBody>
+          <a:bodyPr wrap="square" rtlCol="0">
+            <a:spAutoFit/>
+          </a:bodyPr>
+          <a:lstStyle/>
+          <a:p>
+            <a:pPr algn="ctr"/>
+            <a:r>
+              <a:rPr lang="de-DE" sz="1000" dirty="0"/>
+              <a:t>STOP_MEASUREMENT </a:t>
+            </a:r>
+            <a:r>
+              <a:rPr lang="de-DE" sz="1000" dirty="0" err="1"/>
+              <a:t>package</a:t>
+            </a:r>
+            <a:endParaRPr lang="de-DE" sz="1000" dirty="0"/>
+          </a:p>
+        </p:txBody>
+      </p:sp>
+      <p:sp>
+        <p:nvSpPr>
+          <p:cNvPr id="39" name="Textfeld 38">
+            <a:extLst>
+              <a:ext uri="{FF2B5EF4-FFF2-40B4-BE49-F238E27FC236}">
+                <a16:creationId xmlns:a16="http://schemas.microsoft.com/office/drawing/2014/main" id="{53855DCC-5505-6E1D-CB9D-1C0641A7C7BC}"/>
+              </a:ext>
+            </a:extLst>
+          </p:cNvPr>
+          <p:cNvSpPr txBox="1"/>
+          <p:nvPr/>
+        </p:nvSpPr>
+        <p:spPr>
+          <a:xfrm>
+            <a:off x="7945209" y="2851832"/>
+            <a:ext cx="2434773" cy="400110"/>
+          </a:xfrm>
+          <a:prstGeom prst="rect">
+            <a:avLst/>
+          </a:prstGeom>
+          <a:noFill/>
+        </p:spPr>
+        <p:txBody>
+          <a:bodyPr wrap="square" rtlCol="0">
+            <a:spAutoFit/>
+          </a:bodyPr>
+          <a:lstStyle/>
+          <a:p>
+            <a:pPr algn="ctr"/>
+            <a:r>
+              <a:rPr lang="de-DE" sz="1000" dirty="0" err="1"/>
+              <a:t>oobConnectionCallback</a:t>
+            </a:r>
+            <a:r>
+              <a:rPr lang="de-DE" sz="1000" dirty="0"/>
+              <a:t>. </a:t>
+            </a:r>
+            <a:r>
+              <a:rPr lang="de-DE" sz="1000" dirty="0" err="1"/>
+              <a:t>stopMeasuring</a:t>
+            </a:r>
+            <a:r>
+              <a:rPr lang="de-DE" sz="1000" dirty="0"/>
+              <a:t>()</a:t>
+            </a:r>
+          </a:p>
+        </p:txBody>
+      </p:sp>
+      <p:cxnSp>
+        <p:nvCxnSpPr>
+          <p:cNvPr id="41" name="Gerade Verbindung mit Pfeil 40">
+            <a:extLst>
+              <a:ext uri="{FF2B5EF4-FFF2-40B4-BE49-F238E27FC236}">
+                <a16:creationId xmlns:a16="http://schemas.microsoft.com/office/drawing/2014/main" id="{3167D842-05D0-5A14-EC91-E681B09103B2}"/>
+              </a:ext>
+            </a:extLst>
+          </p:cNvPr>
+          <p:cNvCxnSpPr/>
+          <p:nvPr/>
+        </p:nvCxnSpPr>
+        <p:spPr>
+          <a:xfrm>
+            <a:off x="405039" y="2241455"/>
+            <a:ext cx="986972" cy="0"/>
+          </a:xfrm>
+          <a:prstGeom prst="straightConnector1">
+            <a:avLst/>
+          </a:prstGeom>
+          <a:ln>
+            <a:prstDash val="solid"/>
+            <a:tailEnd type="triangle"/>
+          </a:ln>
+        </p:spPr>
+        <p:style>
+          <a:lnRef idx="2">
+            <a:schemeClr val="accent1"/>
+          </a:lnRef>
+          <a:fillRef idx="0">
+            <a:schemeClr val="accent1"/>
+          </a:fillRef>
+          <a:effectRef idx="1">
+            <a:schemeClr val="accent1"/>
+          </a:effectRef>
+          <a:fontRef idx="minor">
+            <a:schemeClr val="tx1"/>
+          </a:fontRef>
+        </p:style>
+      </p:cxnSp>
+      <p:sp>
+        <p:nvSpPr>
+          <p:cNvPr id="43" name="Textfeld 42">
+            <a:extLst>
+              <a:ext uri="{FF2B5EF4-FFF2-40B4-BE49-F238E27FC236}">
+                <a16:creationId xmlns:a16="http://schemas.microsoft.com/office/drawing/2014/main" id="{FDD47FC1-DFA8-4D53-61E2-945A30E9DB4C}"/>
+              </a:ext>
+            </a:extLst>
+          </p:cNvPr>
+          <p:cNvSpPr txBox="1"/>
+          <p:nvPr/>
+        </p:nvSpPr>
+        <p:spPr>
+          <a:xfrm>
+            <a:off x="638854" y="2370460"/>
+            <a:ext cx="1660077" cy="246221"/>
+          </a:xfrm>
+          <a:prstGeom prst="rect">
+            <a:avLst/>
+          </a:prstGeom>
+          <a:noFill/>
+        </p:spPr>
+        <p:txBody>
+          <a:bodyPr wrap="square" rtlCol="0">
+            <a:spAutoFit/>
+          </a:bodyPr>
+          <a:lstStyle/>
+          <a:p>
+            <a:pPr algn="ctr"/>
+            <a:r>
+              <a:rPr lang="de-DE" sz="1000" dirty="0" err="1"/>
+              <a:t>stopMeasuringBtn</a:t>
+            </a:r>
+            <a:r>
+              <a:rPr lang="de-DE" sz="1000" dirty="0"/>
+              <a:t>()</a:t>
+            </a:r>
+          </a:p>
+        </p:txBody>
+      </p:sp>
+      <p:sp>
+        <p:nvSpPr>
+          <p:cNvPr id="123" name="Textfeld 122">
+            <a:extLst>
+              <a:ext uri="{FF2B5EF4-FFF2-40B4-BE49-F238E27FC236}">
+                <a16:creationId xmlns:a16="http://schemas.microsoft.com/office/drawing/2014/main" id="{4D951A8A-D95C-F0A1-0851-04FC28DA4239}"/>
+              </a:ext>
+            </a:extLst>
+          </p:cNvPr>
+          <p:cNvSpPr txBox="1"/>
+          <p:nvPr/>
+        </p:nvSpPr>
+        <p:spPr>
+          <a:xfrm>
+            <a:off x="4572468" y="177655"/>
+            <a:ext cx="3047064" cy="646331"/>
+          </a:xfrm>
+          <a:prstGeom prst="rect">
+            <a:avLst/>
+          </a:prstGeom>
+          <a:noFill/>
+        </p:spPr>
+        <p:txBody>
+          <a:bodyPr wrap="square" rtlCol="0">
+            <a:spAutoFit/>
+          </a:bodyPr>
+          <a:lstStyle/>
+          <a:p>
+            <a:r>
+              <a:rPr lang="de-DE" dirty="0"/>
+              <a:t>Messung Beenden (symmetrisch)</a:t>
+            </a:r>
+          </a:p>
+        </p:txBody>
+      </p:sp>
+      <p:sp>
+        <p:nvSpPr>
+          <p:cNvPr id="124" name="Textfeld 123">
+            <a:extLst>
+              <a:ext uri="{FF2B5EF4-FFF2-40B4-BE49-F238E27FC236}">
+                <a16:creationId xmlns:a16="http://schemas.microsoft.com/office/drawing/2014/main" id="{71D5ABE1-8226-8B6C-0773-38C582C6AE3F}"/>
+              </a:ext>
+            </a:extLst>
+          </p:cNvPr>
+          <p:cNvSpPr txBox="1"/>
+          <p:nvPr/>
+        </p:nvSpPr>
+        <p:spPr>
+          <a:xfrm>
+            <a:off x="147320" y="1971308"/>
+            <a:ext cx="782956" cy="246221"/>
+          </a:xfrm>
+          <a:prstGeom prst="rect">
+            <a:avLst/>
+          </a:prstGeom>
+          <a:noFill/>
+        </p:spPr>
+        <p:txBody>
+          <a:bodyPr wrap="square" rtlCol="0">
+            <a:spAutoFit/>
+          </a:bodyPr>
+          <a:lstStyle/>
+          <a:p>
+            <a:pPr algn="ctr"/>
+            <a:r>
+              <a:rPr lang="de-DE" sz="1000" dirty="0"/>
+              <a:t>User</a:t>
+            </a:r>
+          </a:p>
+        </p:txBody>
+      </p:sp>
+      <p:sp>
+        <p:nvSpPr>
+          <p:cNvPr id="126" name="Textfeld 125">
+            <a:extLst>
+              <a:ext uri="{FF2B5EF4-FFF2-40B4-BE49-F238E27FC236}">
+                <a16:creationId xmlns:a16="http://schemas.microsoft.com/office/drawing/2014/main" id="{39E7F413-8E09-C6A4-E9CD-A1E09D3343A1}"/>
+              </a:ext>
+            </a:extLst>
+          </p:cNvPr>
+          <p:cNvSpPr txBox="1"/>
+          <p:nvPr/>
+        </p:nvSpPr>
+        <p:spPr>
+          <a:xfrm>
+            <a:off x="9643605" y="3482683"/>
+            <a:ext cx="1660077" cy="246221"/>
+          </a:xfrm>
+          <a:prstGeom prst="rect">
+            <a:avLst/>
+          </a:prstGeom>
+          <a:noFill/>
+        </p:spPr>
+        <p:txBody>
+          <a:bodyPr wrap="square" rtlCol="0">
+            <a:spAutoFit/>
+          </a:bodyPr>
+          <a:lstStyle/>
+          <a:p>
+            <a:pPr algn="ctr"/>
+            <a:r>
+              <a:rPr lang="de-DE" sz="1000" dirty="0" err="1"/>
+              <a:t>rangingSession.close</a:t>
+            </a:r>
+            <a:r>
+              <a:rPr lang="de-DE" sz="1000" dirty="0"/>
+              <a:t>()</a:t>
+            </a:r>
+          </a:p>
+        </p:txBody>
+      </p:sp>
+      <p:sp>
+        <p:nvSpPr>
+          <p:cNvPr id="3" name="Textfeld 2">
+            <a:extLst>
+              <a:ext uri="{FF2B5EF4-FFF2-40B4-BE49-F238E27FC236}">
+                <a16:creationId xmlns:a16="http://schemas.microsoft.com/office/drawing/2014/main" id="{1259E74B-D672-AB6D-CC93-9C5213DEF62E}"/>
+              </a:ext>
+            </a:extLst>
+          </p:cNvPr>
+          <p:cNvSpPr txBox="1"/>
+          <p:nvPr/>
+        </p:nvSpPr>
+        <p:spPr>
+          <a:xfrm>
+            <a:off x="634542" y="2936593"/>
+            <a:ext cx="1660077" cy="246221"/>
+          </a:xfrm>
+          <a:prstGeom prst="rect">
+            <a:avLst/>
+          </a:prstGeom>
+          <a:noFill/>
+        </p:spPr>
+        <p:txBody>
+          <a:bodyPr wrap="square" rtlCol="0">
+            <a:spAutoFit/>
+          </a:bodyPr>
+          <a:lstStyle/>
+          <a:p>
+            <a:pPr algn="ctr"/>
+            <a:r>
+              <a:rPr lang="de-DE" sz="1000" dirty="0" err="1"/>
+              <a:t>stopMeasuring</a:t>
+            </a:r>
+            <a:r>
+              <a:rPr lang="de-DE" sz="1000" dirty="0"/>
+              <a:t> ()</a:t>
+            </a:r>
+          </a:p>
+        </p:txBody>
+      </p:sp>
+    </p:spTree>
+    <p:extLst>
+      <p:ext uri="{BB962C8B-B14F-4D97-AF65-F5344CB8AC3E}">
+        <p14:creationId xmlns:p14="http://schemas.microsoft.com/office/powerpoint/2010/main" val="3979608008"/>
+      </p:ext>
+    </p:extLst>
+  </p:cSld>
+  <p:clrMapOvr>
+    <a:masterClrMapping/>
+  </p:clrMapOvr>
+</p:sld>
+</file>
+
+<file path=ppt/slides/slide3.xml><?xml version="1.0" encoding="utf-8"?>
+<p:sld xmlns:a="http://schemas.openxmlformats.org/drawingml/2006/main" xmlns:r="http://schemas.openxmlformats.org/officeDocument/2006/relationships" xmlns:p="http://schemas.openxmlformats.org/presentationml/2006/main">
+  <p:cSld>
+    <p:spTree>
+      <p:nvGrpSpPr>
+        <p:cNvPr id="1" name="">
+          <a:extLst>
+            <a:ext uri="{FF2B5EF4-FFF2-40B4-BE49-F238E27FC236}">
               <a16:creationId xmlns:a16="http://schemas.microsoft.com/office/drawing/2014/main" id="{3DA32387-A085-C88C-D486-645A3B1A80C8}"/>
             </a:ext>
           </a:extLst>
@@ -5568,7 +6554,7 @@
 </p:sld>
 </file>
 
-<file path=ppt/slides/slide3.xml><?xml version="1.0" encoding="utf-8"?>
+<file path=ppt/slides/slide4.xml><?xml version="1.0" encoding="utf-8"?>
 <p:sld xmlns:a="http://schemas.openxmlformats.org/drawingml/2006/main" xmlns:r="http://schemas.openxmlformats.org/officeDocument/2006/relationships" xmlns:p="http://schemas.openxmlformats.org/presentationml/2006/main">
   <p:cSld>
     <p:spTree>
@@ -6762,7 +7748,7 @@
 </p:sld>
 </file>
 
-<file path=ppt/slides/slide4.xml><?xml version="1.0" encoding="utf-8"?>
+<file path=ppt/slides/slide5.xml><?xml version="1.0" encoding="utf-8"?>
 <p:sld xmlns:a="http://schemas.openxmlformats.org/drawingml/2006/main" xmlns:r="http://schemas.openxmlformats.org/officeDocument/2006/relationships" xmlns:p="http://schemas.openxmlformats.org/presentationml/2006/main">
   <p:cSld>
     <p:spTree>

</xml_diff>

<commit_message>
Testen, debugging, Docs anpassen
</commit_message>
<xml_diff>
--- a/Docs.pptx
+++ b/Docs.pptx
@@ -263,7 +263,7 @@
           <a:p>
             <a:fld id="{191EFF39-64BE-4380-8A53-06CF69B4C7AB}" type="datetimeFigureOut">
               <a:rPr lang="de-DE" smtClean="0"/>
-              <a:t>16.07.2026</a:t>
+              <a:t>24.07.2026</a:t>
             </a:fld>
             <a:endParaRPr lang="de-DE"/>
           </a:p>
@@ -461,7 +461,7 @@
           <a:p>
             <a:fld id="{191EFF39-64BE-4380-8A53-06CF69B4C7AB}" type="datetimeFigureOut">
               <a:rPr lang="de-DE" smtClean="0"/>
-              <a:t>16.07.2026</a:t>
+              <a:t>24.07.2026</a:t>
             </a:fld>
             <a:endParaRPr lang="de-DE"/>
           </a:p>
@@ -669,7 +669,7 @@
           <a:p>
             <a:fld id="{191EFF39-64BE-4380-8A53-06CF69B4C7AB}" type="datetimeFigureOut">
               <a:rPr lang="de-DE" smtClean="0"/>
-              <a:t>16.07.2026</a:t>
+              <a:t>24.07.2026</a:t>
             </a:fld>
             <a:endParaRPr lang="de-DE"/>
           </a:p>
@@ -867,7 +867,7 @@
           <a:p>
             <a:fld id="{191EFF39-64BE-4380-8A53-06CF69B4C7AB}" type="datetimeFigureOut">
               <a:rPr lang="de-DE" smtClean="0"/>
-              <a:t>16.07.2026</a:t>
+              <a:t>24.07.2026</a:t>
             </a:fld>
             <a:endParaRPr lang="de-DE"/>
           </a:p>
@@ -1142,7 +1142,7 @@
           <a:p>
             <a:fld id="{191EFF39-64BE-4380-8A53-06CF69B4C7AB}" type="datetimeFigureOut">
               <a:rPr lang="de-DE" smtClean="0"/>
-              <a:t>16.07.2026</a:t>
+              <a:t>24.07.2026</a:t>
             </a:fld>
             <a:endParaRPr lang="de-DE"/>
           </a:p>
@@ -1407,7 +1407,7 @@
           <a:p>
             <a:fld id="{191EFF39-64BE-4380-8A53-06CF69B4C7AB}" type="datetimeFigureOut">
               <a:rPr lang="de-DE" smtClean="0"/>
-              <a:t>16.07.2026</a:t>
+              <a:t>24.07.2026</a:t>
             </a:fld>
             <a:endParaRPr lang="de-DE"/>
           </a:p>
@@ -1819,7 +1819,7 @@
           <a:p>
             <a:fld id="{191EFF39-64BE-4380-8A53-06CF69B4C7AB}" type="datetimeFigureOut">
               <a:rPr lang="de-DE" smtClean="0"/>
-              <a:t>16.07.2026</a:t>
+              <a:t>24.07.2026</a:t>
             </a:fld>
             <a:endParaRPr lang="de-DE"/>
           </a:p>
@@ -1960,7 +1960,7 @@
           <a:p>
             <a:fld id="{191EFF39-64BE-4380-8A53-06CF69B4C7AB}" type="datetimeFigureOut">
               <a:rPr lang="de-DE" smtClean="0"/>
-              <a:t>16.07.2026</a:t>
+              <a:t>24.07.2026</a:t>
             </a:fld>
             <a:endParaRPr lang="de-DE"/>
           </a:p>
@@ -2073,7 +2073,7 @@
           <a:p>
             <a:fld id="{191EFF39-64BE-4380-8A53-06CF69B4C7AB}" type="datetimeFigureOut">
               <a:rPr lang="de-DE" smtClean="0"/>
-              <a:t>16.07.2026</a:t>
+              <a:t>24.07.2026</a:t>
             </a:fld>
             <a:endParaRPr lang="de-DE"/>
           </a:p>
@@ -2384,7 +2384,7 @@
           <a:p>
             <a:fld id="{191EFF39-64BE-4380-8A53-06CF69B4C7AB}" type="datetimeFigureOut">
               <a:rPr lang="de-DE" smtClean="0"/>
-              <a:t>16.07.2026</a:t>
+              <a:t>24.07.2026</a:t>
             </a:fld>
             <a:endParaRPr lang="de-DE"/>
           </a:p>
@@ -2672,7 +2672,7 @@
           <a:p>
             <a:fld id="{191EFF39-64BE-4380-8A53-06CF69B4C7AB}" type="datetimeFigureOut">
               <a:rPr lang="de-DE" smtClean="0"/>
-              <a:t>16.07.2026</a:t>
+              <a:t>24.07.2026</a:t>
             </a:fld>
             <a:endParaRPr lang="de-DE"/>
           </a:p>
@@ -2913,7 +2913,7 @@
           <a:p>
             <a:fld id="{191EFF39-64BE-4380-8A53-06CF69B4C7AB}" type="datetimeFigureOut">
               <a:rPr lang="de-DE" smtClean="0"/>
-              <a:t>16.07.2026</a:t>
+              <a:t>24.07.2026</a:t>
             </a:fld>
             <a:endParaRPr lang="de-DE"/>
           </a:p>
@@ -3805,45 +3805,6 @@
           </a:p>
         </p:txBody>
       </p:sp>
-      <p:sp>
-        <p:nvSpPr>
-          <p:cNvPr id="27" name="Textfeld 26">
-            <a:extLst>
-              <a:ext uri="{FF2B5EF4-FFF2-40B4-BE49-F238E27FC236}">
-                <a16:creationId xmlns:a16="http://schemas.microsoft.com/office/drawing/2014/main" id="{9EE9F1B0-E4A4-B85A-12B5-5FA516CD84D9}"/>
-              </a:ext>
-            </a:extLst>
-          </p:cNvPr>
-          <p:cNvSpPr txBox="1"/>
-          <p:nvPr/>
-        </p:nvSpPr>
-        <p:spPr>
-          <a:xfrm>
-            <a:off x="1651452" y="2620126"/>
-            <a:ext cx="2434773" cy="246221"/>
-          </a:xfrm>
-          <a:prstGeom prst="rect">
-            <a:avLst/>
-          </a:prstGeom>
-          <a:noFill/>
-        </p:spPr>
-        <p:txBody>
-          <a:bodyPr wrap="square" rtlCol="0">
-            <a:spAutoFit/>
-          </a:bodyPr>
-          <a:lstStyle/>
-          <a:p>
-            <a:r>
-              <a:rPr lang="de-DE" sz="1000" dirty="0" err="1"/>
-              <a:t>oobConnector.requestMeasuring</a:t>
-            </a:r>
-            <a:r>
-              <a:rPr lang="de-DE" sz="1000" dirty="0"/>
-              <a:t>()</a:t>
-            </a:r>
-          </a:p>
-        </p:txBody>
-      </p:sp>
       <p:cxnSp>
         <p:nvCxnSpPr>
           <p:cNvPr id="29" name="Gerade Verbindung mit Pfeil 28">
@@ -4005,54 +3966,6 @@
           </a:p>
         </p:txBody>
       </p:sp>
-      <p:sp>
-        <p:nvSpPr>
-          <p:cNvPr id="39" name="Textfeld 38">
-            <a:extLst>
-              <a:ext uri="{FF2B5EF4-FFF2-40B4-BE49-F238E27FC236}">
-                <a16:creationId xmlns:a16="http://schemas.microsoft.com/office/drawing/2014/main" id="{72BD8BA9-904E-0F53-8F1C-0C74D75C76F3}"/>
-              </a:ext>
-            </a:extLst>
-          </p:cNvPr>
-          <p:cNvSpPr txBox="1"/>
-          <p:nvPr/>
-        </p:nvSpPr>
-        <p:spPr>
-          <a:xfrm>
-            <a:off x="7945209" y="2851832"/>
-            <a:ext cx="2434773" cy="400110"/>
-          </a:xfrm>
-          <a:prstGeom prst="rect">
-            <a:avLst/>
-          </a:prstGeom>
-          <a:noFill/>
-        </p:spPr>
-        <p:txBody>
-          <a:bodyPr wrap="square" rtlCol="0">
-            <a:spAutoFit/>
-          </a:bodyPr>
-          <a:lstStyle/>
-          <a:p>
-            <a:pPr algn="ctr"/>
-            <a:r>
-              <a:rPr lang="de-DE" sz="1000" dirty="0" err="1"/>
-              <a:t>oobConnectionCallback</a:t>
-            </a:r>
-            <a:r>
-              <a:rPr lang="de-DE" sz="1000" dirty="0"/>
-              <a:t>. </a:t>
-            </a:r>
-            <a:r>
-              <a:rPr lang="de-DE" sz="1000" dirty="0" err="1"/>
-              <a:t>requestMeasuring</a:t>
-            </a:r>
-            <a:r>
-              <a:rPr lang="de-DE" sz="1000" dirty="0"/>
-              <a:t>()</a:t>
-            </a:r>
-          </a:p>
-        </p:txBody>
-      </p:sp>
       <p:cxnSp>
         <p:nvCxnSpPr>
           <p:cNvPr id="41" name="Gerade Verbindung mit Pfeil 40">
@@ -4382,94 +4295,6 @@
           </a:fontRef>
         </p:style>
       </p:cxnSp>
-      <p:sp>
-        <p:nvSpPr>
-          <p:cNvPr id="62" name="Textfeld 61">
-            <a:extLst>
-              <a:ext uri="{FF2B5EF4-FFF2-40B4-BE49-F238E27FC236}">
-                <a16:creationId xmlns:a16="http://schemas.microsoft.com/office/drawing/2014/main" id="{E85983FE-459F-C4C2-7F05-3424A8904007}"/>
-              </a:ext>
-            </a:extLst>
-          </p:cNvPr>
-          <p:cNvSpPr txBox="1"/>
-          <p:nvPr/>
-        </p:nvSpPr>
-        <p:spPr>
-          <a:xfrm>
-            <a:off x="1383393" y="4433675"/>
-            <a:ext cx="2431143" cy="400110"/>
-          </a:xfrm>
-          <a:prstGeom prst="rect">
-            <a:avLst/>
-          </a:prstGeom>
-          <a:noFill/>
-        </p:spPr>
-        <p:txBody>
-          <a:bodyPr wrap="square">
-            <a:spAutoFit/>
-          </a:bodyPr>
-          <a:lstStyle/>
-          <a:p>
-            <a:pPr algn="ctr"/>
-            <a:r>
-              <a:rPr lang="de-DE" sz="1000" dirty="0" err="1"/>
-              <a:t>oobConnectionCallback</a:t>
-            </a:r>
-            <a:r>
-              <a:rPr lang="de-DE" sz="1000" dirty="0"/>
-              <a:t>. </a:t>
-            </a:r>
-            <a:r>
-              <a:rPr lang="de-DE" sz="1000" dirty="0" err="1"/>
-              <a:t>startMeasuringOrder</a:t>
-            </a:r>
-            <a:r>
-              <a:rPr lang="de-DE" sz="1000" dirty="0"/>
-              <a:t>()</a:t>
-            </a:r>
-          </a:p>
-        </p:txBody>
-      </p:sp>
-      <p:sp>
-        <p:nvSpPr>
-          <p:cNvPr id="64" name="Textfeld 63">
-            <a:extLst>
-              <a:ext uri="{FF2B5EF4-FFF2-40B4-BE49-F238E27FC236}">
-                <a16:creationId xmlns:a16="http://schemas.microsoft.com/office/drawing/2014/main" id="{F5947DA8-CE61-D516-275E-5E349C4F760A}"/>
-              </a:ext>
-            </a:extLst>
-          </p:cNvPr>
-          <p:cNvSpPr txBox="1"/>
-          <p:nvPr/>
-        </p:nvSpPr>
-        <p:spPr>
-          <a:xfrm>
-            <a:off x="7970609" y="3941495"/>
-            <a:ext cx="2434773" cy="246221"/>
-          </a:xfrm>
-          <a:prstGeom prst="rect">
-            <a:avLst/>
-          </a:prstGeom>
-          <a:noFill/>
-        </p:spPr>
-        <p:txBody>
-          <a:bodyPr wrap="square" rtlCol="0">
-            <a:spAutoFit/>
-          </a:bodyPr>
-          <a:lstStyle/>
-          <a:p>
-            <a:pPr algn="ctr"/>
-            <a:r>
-              <a:rPr lang="de-DE" sz="1000" dirty="0" err="1"/>
-              <a:t>oobConnector.startMeasuring</a:t>
-            </a:r>
-            <a:r>
-              <a:rPr lang="de-DE" sz="1000" dirty="0"/>
-              <a:t>()</a:t>
-            </a:r>
-          </a:p>
-        </p:txBody>
-      </p:sp>
       <p:sp>
         <p:nvSpPr>
           <p:cNvPr id="66" name="Textfeld 65">
@@ -5168,45 +4993,6 @@
           </a:p>
         </p:txBody>
       </p:sp>
-      <p:sp>
-        <p:nvSpPr>
-          <p:cNvPr id="27" name="Textfeld 26">
-            <a:extLst>
-              <a:ext uri="{FF2B5EF4-FFF2-40B4-BE49-F238E27FC236}">
-                <a16:creationId xmlns:a16="http://schemas.microsoft.com/office/drawing/2014/main" id="{78545669-2938-BDAA-6D34-6C11D23F4FA1}"/>
-              </a:ext>
-            </a:extLst>
-          </p:cNvPr>
-          <p:cNvSpPr txBox="1"/>
-          <p:nvPr/>
-        </p:nvSpPr>
-        <p:spPr>
-          <a:xfrm>
-            <a:off x="1651452" y="2620126"/>
-            <a:ext cx="2434773" cy="246221"/>
-          </a:xfrm>
-          <a:prstGeom prst="rect">
-            <a:avLst/>
-          </a:prstGeom>
-          <a:noFill/>
-        </p:spPr>
-        <p:txBody>
-          <a:bodyPr wrap="square" rtlCol="0">
-            <a:spAutoFit/>
-          </a:bodyPr>
-          <a:lstStyle/>
-          <a:p>
-            <a:r>
-              <a:rPr lang="de-DE" sz="1000" dirty="0" err="1"/>
-              <a:t>oobConnector.stopMeasuring</a:t>
-            </a:r>
-            <a:r>
-              <a:rPr lang="de-DE" sz="1000" dirty="0"/>
-              <a:t>()</a:t>
-            </a:r>
-          </a:p>
-        </p:txBody>
-      </p:sp>
       <p:cxnSp>
         <p:nvCxnSpPr>
           <p:cNvPr id="29" name="Gerade Verbindung mit Pfeil 28">
@@ -5365,54 +5151,6 @@
               <a:t>package</a:t>
             </a:r>
             <a:endParaRPr lang="de-DE" sz="1000" dirty="0"/>
-          </a:p>
-        </p:txBody>
-      </p:sp>
-      <p:sp>
-        <p:nvSpPr>
-          <p:cNvPr id="39" name="Textfeld 38">
-            <a:extLst>
-              <a:ext uri="{FF2B5EF4-FFF2-40B4-BE49-F238E27FC236}">
-                <a16:creationId xmlns:a16="http://schemas.microsoft.com/office/drawing/2014/main" id="{53855DCC-5505-6E1D-CB9D-1C0641A7C7BC}"/>
-              </a:ext>
-            </a:extLst>
-          </p:cNvPr>
-          <p:cNvSpPr txBox="1"/>
-          <p:nvPr/>
-        </p:nvSpPr>
-        <p:spPr>
-          <a:xfrm>
-            <a:off x="7945209" y="2851832"/>
-            <a:ext cx="2434773" cy="400110"/>
-          </a:xfrm>
-          <a:prstGeom prst="rect">
-            <a:avLst/>
-          </a:prstGeom>
-          <a:noFill/>
-        </p:spPr>
-        <p:txBody>
-          <a:bodyPr wrap="square" rtlCol="0">
-            <a:spAutoFit/>
-          </a:bodyPr>
-          <a:lstStyle/>
-          <a:p>
-            <a:pPr algn="ctr"/>
-            <a:r>
-              <a:rPr lang="de-DE" sz="1000" dirty="0" err="1"/>
-              <a:t>oobConnectionCallback</a:t>
-            </a:r>
-            <a:r>
-              <a:rPr lang="de-DE" sz="1000" dirty="0"/>
-              <a:t>. </a:t>
-            </a:r>
-            <a:r>
-              <a:rPr lang="de-DE" sz="1000" dirty="0" err="1"/>
-              <a:t>stopMeasuring</a:t>
-            </a:r>
-            <a:r>
-              <a:rPr lang="de-DE" sz="1000" dirty="0"/>
-              <a:t>()</a:t>
-            </a:r>
           </a:p>
         </p:txBody>
       </p:sp>
@@ -6376,10 +6114,10 @@
       </p:sp>
       <p:sp>
         <p:nvSpPr>
-          <p:cNvPr id="80" name="Textfeld 79">
-            <a:extLst>
-              <a:ext uri="{FF2B5EF4-FFF2-40B4-BE49-F238E27FC236}">
-                <a16:creationId xmlns:a16="http://schemas.microsoft.com/office/drawing/2014/main" id="{B6FAFB90-4595-7CF5-EF25-13A29E10E6F2}"/>
+          <p:cNvPr id="82" name="Textfeld 81">
+            <a:extLst>
+              <a:ext uri="{FF2B5EF4-FFF2-40B4-BE49-F238E27FC236}">
+                <a16:creationId xmlns:a16="http://schemas.microsoft.com/office/drawing/2014/main" id="{5E0B938D-F1C1-5FCE-74C4-4613A9137C81}"/>
               </a:ext>
             </a:extLst>
           </p:cNvPr>
@@ -6388,7 +6126,7 @@
         </p:nvSpPr>
         <p:spPr>
           <a:xfrm>
-            <a:off x="7991476" y="3822700"/>
+            <a:off x="4681309" y="4015198"/>
             <a:ext cx="2434773" cy="246221"/>
           </a:xfrm>
           <a:prstGeom prst="rect">
@@ -6404,46 +6142,6 @@
           <a:p>
             <a:pPr algn="ctr"/>
             <a:r>
-              <a:rPr lang="de-DE" sz="1000" dirty="0" err="1"/>
-              <a:t>oobConnector.shareResult</a:t>
-            </a:r>
-            <a:r>
-              <a:rPr lang="de-DE" sz="1000" dirty="0"/>
-              <a:t>()</a:t>
-            </a:r>
-          </a:p>
-        </p:txBody>
-      </p:sp>
-      <p:sp>
-        <p:nvSpPr>
-          <p:cNvPr id="82" name="Textfeld 81">
-            <a:extLst>
-              <a:ext uri="{FF2B5EF4-FFF2-40B4-BE49-F238E27FC236}">
-                <a16:creationId xmlns:a16="http://schemas.microsoft.com/office/drawing/2014/main" id="{5E0B938D-F1C1-5FCE-74C4-4613A9137C81}"/>
-              </a:ext>
-            </a:extLst>
-          </p:cNvPr>
-          <p:cNvSpPr txBox="1"/>
-          <p:nvPr/>
-        </p:nvSpPr>
-        <p:spPr>
-          <a:xfrm>
-            <a:off x="4681309" y="4015198"/>
-            <a:ext cx="2434773" cy="246221"/>
-          </a:xfrm>
-          <a:prstGeom prst="rect">
-            <a:avLst/>
-          </a:prstGeom>
-          <a:noFill/>
-        </p:spPr>
-        <p:txBody>
-          <a:bodyPr wrap="square" rtlCol="0">
-            <a:spAutoFit/>
-          </a:bodyPr>
-          <a:lstStyle/>
-          <a:p>
-            <a:pPr algn="ctr"/>
-            <a:r>
               <a:rPr lang="de-DE" sz="1000" dirty="0"/>
               <a:t>SHARED_RESULT </a:t>
             </a:r>
@@ -6452,57 +6150,6 @@
               <a:t>package</a:t>
             </a:r>
             <a:endParaRPr lang="de-DE" sz="1000" dirty="0"/>
-          </a:p>
-        </p:txBody>
-      </p:sp>
-      <p:sp>
-        <p:nvSpPr>
-          <p:cNvPr id="84" name="Textfeld 83">
-            <a:extLst>
-              <a:ext uri="{FF2B5EF4-FFF2-40B4-BE49-F238E27FC236}">
-                <a16:creationId xmlns:a16="http://schemas.microsoft.com/office/drawing/2014/main" id="{1202A08E-7C62-B946-4A55-655F50BFCF02}"/>
-              </a:ext>
-            </a:extLst>
-          </p:cNvPr>
-          <p:cNvSpPr txBox="1"/>
-          <p:nvPr/>
-        </p:nvSpPr>
-        <p:spPr>
-          <a:xfrm>
-            <a:off x="1524454" y="4159953"/>
-            <a:ext cx="2431143" cy="400110"/>
-          </a:xfrm>
-          <a:prstGeom prst="rect">
-            <a:avLst/>
-          </a:prstGeom>
-          <a:noFill/>
-        </p:spPr>
-        <p:txBody>
-          <a:bodyPr wrap="square">
-            <a:spAutoFit/>
-          </a:bodyPr>
-          <a:lstStyle/>
-          <a:p>
-            <a:pPr algn="ctr"/>
-            <a:r>
-              <a:rPr lang="de-DE" sz="1000" dirty="0" err="1"/>
-              <a:t>oobConnectionCallback</a:t>
-            </a:r>
-            <a:r>
-              <a:rPr lang="de-DE" sz="1000" dirty="0"/>
-              <a:t>.</a:t>
-            </a:r>
-          </a:p>
-          <a:p>
-            <a:pPr algn="ctr"/>
-            <a:r>
-              <a:rPr lang="de-DE" sz="1000" dirty="0" err="1"/>
-              <a:t>sharedResult</a:t>
-            </a:r>
-            <a:r>
-              <a:rPr lang="de-DE" sz="1000" dirty="0"/>
-              <a:t>()</a:t>
-            </a:r>
           </a:p>
         </p:txBody>
       </p:sp>

</xml_diff>